<commit_message>
docs: correct grant claims, add MIT license
</commit_message>
<xml_diff>
--- a/docs/fundit-pitch-deck.pptx
+++ b/docs/fundit-pitch-deck.pptx
@@ -116,39 +116,39 @@
   <p:extLst>
     <p:ext uri="{521415D9-36F7-43E2-AB2F-B90AF26B5E84}">
       <p14:sectionLst xmlns:p14="http://schemas.microsoft.com/office/powerpoint/2010/main">
-        <p14:section name="Opening" id="{3d28ed98-ada3-41b0-69dd-f3229842d395}">
+        <p14:section name="Opening" id="{679d5e46-9537-6d35-3ca0-c35144b180b0}">
           <p14:sldIdLst>
             <p14:sldId id="256"/>
           </p14:sldIdLst>
         </p14:section>
-        <p14:section name="Problem" id="{6476666b-dfdd-c942-26e1-9b4b7059b755}">
+        <p14:section name="Problem" id="{7f247460-3e9c-c11b-51bb-ead51483ccd9}">
           <p14:sldIdLst>
             <p14:sldId id="257"/>
           </p14:sldIdLst>
         </p14:section>
-        <p14:section name="Product" id="{bc447e81-5a60-04e6-3256-6b35f663897f}">
+        <p14:section name="Product" id="{d9c7f40b-8050-73bb-baaa-069215453945}">
           <p14:sldIdLst>
             <p14:sldId id="258"/>
             <p14:sldId id="259"/>
           </p14:sldIdLst>
         </p14:section>
-        <p14:section name="Circle stack" id="{3db6e131-e78e-44eb-6148-bc4160a774b4}">
+        <p14:section name="Circle stack" id="{b92fa254-66c1-a114-42c4-6f0fc81679c5}">
           <p14:sldIdLst>
             <p14:sldId id="260"/>
           </p14:sldIdLst>
         </p14:section>
-        <p14:section name="Trust" id="{2c0da678-c2a4-9eda-8c2a-2d1014b4788f}">
+        <p14:section name="Trust" id="{9d5d788f-b52c-b3d2-9138-d4b7f1650185}">
           <p14:sldIdLst>
             <p14:sldId id="261"/>
             <p14:sldId id="262"/>
           </p14:sldIdLst>
         </p14:section>
-        <p14:section name="Status" id="{0a56c3f2-93f5-af5f-721e-a33366776f01}">
+        <p14:section name="Status" id="{ef740703-2a37-80ec-dab0-87b4dda15b45}">
           <p14:sldIdLst>
             <p14:sldId id="263"/>
           </p14:sldIdLst>
         </p14:section>
-        <p14:section name="Ask" id="{64e97773-bafb-e6d6-4778-acdde0f69750}">
+        <p14:section name="Ask" id="{c04a4778-fd71-7bb1-c98b-867b870b3efd}">
           <p14:sldIdLst>
             <p14:sldId id="264"/>
             <p14:sldId id="265"/>
@@ -822,7 +822,7 @@
           <a:p>
             <a:r>
               <a:rPr lang="en-US" dirty="0"/>
-              <a:t>0:30 to 1:45. Demo path: create a campaign, donate 1 USDC with a tip and message, show the activity list and explorer link, then withdraw to Base.</a:t>
+              <a:t>0:30 to 1:45. Only after the mainnet deploy; before then, demo the fork build. Demo path: create a campaign, donate 1 USDC with a tip and message, show the activity list and explorer link, then withdraw to Base (only after canary C4 passes).</a:t>
             </a:r>
             <a:endParaRPr lang="en-US" dirty="0"/>
           </a:p>
@@ -910,7 +910,7 @@
           <a:p>
             <a:r>
               <a:rPr lang="en-US" dirty="0"/>
-              <a:t>Walk the money: three donor paths in, one escrow, payouts out. The owner has no path to the funds.</a:t>
+              <a:t>Walk the money: three donor paths in, one escrow, payouts out. The owner has no path to a creator balance. Treasury rotation only affects where unclaimed fees go.</a:t>
             </a:r>
             <a:endParaRPr lang="en-US" dirty="0"/>
           </a:p>
@@ -998,7 +998,7 @@
           <a:p>
             <a:r>
               <a:rPr lang="en-US" dirty="0"/>
-              <a:t>1:45 to 2:30. Four products are on at launch. Three more are built and fork-tested, and turn on only after the live canary proves them.</a:t>
+              <a:t>1:45 to 2:30. Four products are planned for launch, pending canary steps C2 and C4. Cross-chain donations, unified balance donations and passkeys are built and unit-tested with mocks. On an Arc mainnet fork, the end-to-end suite simulates a forwarded mint (a plain USDC transfer and a stubbed Iris response). No Bridge Kit, Gateway or Modular Wallets call has run against Arc yet. They stay off until the live canary confirms them.</a:t>
             </a:r>
             <a:endParaRPr lang="en-US" dirty="0"/>
           </a:p>
@@ -1086,7 +1086,7 @@
           <a:p>
             <a:r>
               <a:rPr lang="en-US" dirty="0"/>
-              <a:t>2:30 to 3:15. Enforced in immutable code. Fees are pulled, so a broken treasury never blocks a donation or withdrawal. No backend, no database, no server with keys.</a:t>
+              <a:t>2:30 to 3:15. Enforced in immutable code, and renounceOwnership always reverts. Fees are pulled, so a broken treasury never blocks a donation or withdrawal. A new treasury also collects unclaimed fees and tips. The app is a static site.</a:t>
             </a:r>
             <a:endParaRPr lang="en-US" dirty="0"/>
           </a:p>
@@ -2158,7 +2158,7 @@
                 <a:ea typeface="Calibri" pitchFamily="34" charset="-122"/>
                 <a:cs typeface="Calibri" pitchFamily="34" charset="-120"/>
               </a:rPr>
-              <a:t>Every fundraiser is its own USDC or EURC escrow contract. Only the creator can withdraw, and anyone can audit every dollar.</a:t>
+              <a:t>Every fundraiser is its own USDC or EURC escrow contract. Only the creator can withdraw, and anyone can audit every inflow and outflow.</a:t>
             </a:r>
             <a:endParaRPr lang="en-US" sz="1800" dirty="0"/>
           </a:p>
@@ -3690,7 +3690,7 @@
                   <a:schemeClr val="tx2"/>
                 </a:solidFill>
               </a:rPr>
-              <a:t>EIP-1167 clone. Holds USDC or EURC. Owner cannot move funds.</a:t>
+              <a:t>EIP-1167 clone. Holds USDC or EURC. Owner cannot move creator balances.</a:t>
             </a:r>
             <a:endParaRPr lang="en-US" sz="1400" dirty="0"/>
           </a:p>
@@ -4500,7 +4500,7 @@
                           <a:ea typeface="Calibri" pitchFamily="34" charset="-122"/>
                           <a:cs typeface="Calibri" pitchFamily="34" charset="-120"/>
                         </a:rPr>
-                        <a:t>Status</a:t>
+                        <a:t>Planned at launch</a:t>
                       </a:r>
                       <a:endParaRPr lang="en-US" sz="1200" dirty="0">
                         <a:latin typeface="Calibri" charset="0"/>
@@ -4700,7 +4700,7 @@
                           <a:ea typeface="Calibri" pitchFamily="34" charset="-122"/>
                           <a:cs typeface="Calibri" pitchFamily="34" charset="-120"/>
                         </a:rPr>
-                        <a:t>On at launch</a:t>
+                        <a:t>Planned</a:t>
                       </a:r>
                       <a:endParaRPr lang="en-US" sz="1300" dirty="0">
                         <a:latin typeface="Calibri" charset="0"/>
@@ -4897,7 +4897,7 @@
                           <a:ea typeface="Calibri" pitchFamily="34" charset="-122"/>
                           <a:cs typeface="Calibri" pitchFamily="34" charset="-120"/>
                         </a:rPr>
-                        <a:t>On at launch</a:t>
+                        <a:t>Planned</a:t>
                       </a:r>
                       <a:endParaRPr lang="en-US" sz="1300" dirty="0">
                         <a:latin typeface="Calibri" charset="0"/>
@@ -5094,7 +5094,7 @@
                           <a:ea typeface="Calibri" pitchFamily="34" charset="-122"/>
                           <a:cs typeface="Calibri" pitchFamily="34" charset="-120"/>
                         </a:rPr>
-                        <a:t>On at launch</a:t>
+                        <a:t>Planned</a:t>
                       </a:r>
                       <a:endParaRPr lang="en-US" sz="1300" dirty="0">
                         <a:latin typeface="Calibri" charset="0"/>
@@ -5291,7 +5291,7 @@
                           <a:ea typeface="Calibri" pitchFamily="34" charset="-122"/>
                           <a:cs typeface="Calibri" pitchFamily="34" charset="-120"/>
                         </a:rPr>
-                        <a:t>On at launch</a:t>
+                        <a:t>Planned</a:t>
                       </a:r>
                       <a:endParaRPr lang="en-US" sz="1300" dirty="0">
                         <a:latin typeface="Calibri" charset="0"/>
@@ -6139,7 +6139,7 @@
                   <a:schemeClr val="tx1"/>
                 </a:solidFill>
               </a:rPr>
-              <a:t>Set fees for new campaigns, each at most 5%. Rotate the treasury. Feature a campaign. Pause new campaigns.</a:t>
+              <a:t>Set fees for new campaigns, each at most 5%. Set the treasury, which also receives unclaimed fees and tips. Feature a campaign. Pause new campaigns.</a:t>
             </a:r>
             <a:endParaRPr lang="en-US" sz="1400" dirty="0"/>
           </a:p>
@@ -6238,7 +6238,7 @@
                   <a:schemeClr val="tx1"/>
                 </a:solidFill>
               </a:rPr>
-              <a:t>Move, freeze or redirect funds. Pause donations or withdrawals. Change an existing campaign. Upgrade a contract.</a:t>
+              <a:t>Move, freeze or redirect a creator's balance. Pause donations or withdrawals. Change an existing campaign's fees, token or creator.</a:t>
             </a:r>
             <a:endParaRPr lang="en-US" sz="1400" dirty="0"/>
           </a:p>
@@ -6709,7 +6709,7 @@
                   <a:schemeClr val="tx2"/>
                 </a:solidFill>
               </a:rPr>
-              <a:t>Fees are copied into each campaign when it is created and never change for that campaign. Donors can add an optional tip. Fundit runs on a static site and free hosting, so there is no infrastructure bill.</a:t>
+              <a:t>Fees are copied into each campaign when it is created and never change for that campaign. Donors can add an optional tip. Fundit will run as a static site on free hosting, so there is no infrastructure bill.</a:t>
             </a:r>
             <a:endParaRPr lang="en-US" sz="1400" dirty="0"/>
           </a:p>
@@ -7117,7 +7117,7 @@
                   <a:schemeClr val="tx1"/>
                 </a:solidFill>
               </a:rPr>
-              <a:t>Cross-chain donations, unified balance donations and passkeys turn on only after the live canary confirms each.</a:t>
+              <a:t>Cross-chain donations, unified balance donations and passkeys are unit-tested with mocks. They turn on only after the live canary confirms each.</a:t>
             </a:r>
             <a:endParaRPr lang="en-US" sz="1400" dirty="0"/>
           </a:p>

</xml_diff>

<commit_message>
docs: refresh pitch deck and whitepaper PDF
</commit_message>
<xml_diff>
--- a/docs/fundit-pitch-deck.pptx
+++ b/docs/fundit-pitch-deck.pptx
@@ -2265,7 +2265,7 @@
                 <a:ea typeface="Calibri" pitchFamily="34" charset="-122"/>
                 <a:cs typeface="Calibri" pitchFamily="34" charset="-120"/>
               </a:rPr>
-              <a:t>A Circle Developer Grant with milestone-based USDC payments, and a technical review from the CCTP team on forwarded mints into contract recipients.</a:t>
+              <a:t>A Circle Developer Grant with milestone-based USDC payments, to release passkey sign-in, add money from other chains and fund a third-party audit.</a:t>
             </a:r>
             <a:endParaRPr lang="en-US" sz="1800" dirty="0"/>
           </a:p>
@@ -2769,6 +2769,10 @@
             <a:prstDash val="solid"/>
           </a:ln>
         </p:spPr>
+        <p:txBody>
+          <a:bodyPr/>
+          <a:p/>
+        </p:txBody>
       </p:sp>
       <p:sp>
         <p:nvSpPr>
@@ -2902,6 +2906,10 @@
             <a:prstDash val="solid"/>
           </a:ln>
         </p:spPr>
+        <p:txBody>
+          <a:bodyPr/>
+          <a:p/>
+        </p:txBody>
       </p:sp>
       <p:sp>
         <p:nvSpPr>
@@ -3005,7 +3013,7 @@
                   <a:schemeClr val="tx1"/>
                 </a:solidFill>
               </a:rPr>
-              <a:t>Approve, then donate on Arc. Arc Memo tags the donation and keeps the donor as sender.</a:t>
+              <a:t>Give from your Fundit account with a passkey. Approve and donate go in one step.</a:t>
             </a:r>
             <a:endParaRPr lang="en-US" sz="1400" dirty="0"/>
           </a:p>
@@ -3035,6 +3043,10 @@
             <a:prstDash val="solid"/>
           </a:ln>
         </p:spPr>
+        <p:txBody>
+          <a:bodyPr/>
+          <a:p/>
+        </p:txBody>
       </p:sp>
       <p:sp>
         <p:nvSpPr>
@@ -3168,6 +3180,10 @@
             <a:prstDash val="solid"/>
           </a:ln>
         </p:spPr>
+        <p:txBody>
+          <a:bodyPr/>
+          <a:p/>
+        </p:txBody>
       </p:sp>
       <p:sp>
         <p:nvSpPr>
@@ -3414,6 +3430,10 @@
             <a:prstDash val="solid"/>
           </a:ln>
         </p:spPr>
+        <p:txBody>
+          <a:bodyPr/>
+          <a:p/>
+        </p:txBody>
       </p:sp>
       <p:sp>
         <p:nvSpPr>
@@ -3445,7 +3465,7 @@
                   <a:schemeClr val="tx1"/>
                 </a:solidFill>
               </a:rPr>
-              <a:t>Donor on Arc</a:t>
+              <a:t>Donor's Fundit account</a:t>
             </a:r>
             <a:endParaRPr lang="en-US" sz="1400" dirty="0"/>
           </a:p>
@@ -3459,7 +3479,7 @@
                   <a:schemeClr val="tx2"/>
                 </a:solidFill>
               </a:rPr>
-              <a:t>Memo.memo, then donate()</a:t>
+              <a:t>Passkey, then donate()</a:t>
             </a:r>
             <a:endParaRPr lang="en-US" sz="1400" dirty="0"/>
           </a:p>
@@ -3491,6 +3511,10 @@
             <a:prstDash val="solid"/>
           </a:ln>
         </p:spPr>
+        <p:txBody>
+          <a:bodyPr/>
+          <a:p/>
+        </p:txBody>
       </p:sp>
       <p:sp>
         <p:nvSpPr>
@@ -3522,7 +3546,7 @@
                   <a:schemeClr val="tx1"/>
                 </a:solidFill>
               </a:rPr>
-              <a:t>Donor on another chain</a:t>
+              <a:t>Other CCTP chain</a:t>
             </a:r>
             <a:endParaRPr lang="en-US" sz="1400" dirty="0"/>
           </a:p>
@@ -3536,7 +3560,7 @@
                   <a:schemeClr val="tx2"/>
                 </a:solidFill>
               </a:rPr>
-              <a:t>Bridge Kit, CCTP V2 burn</a:t>
+              <a:t>CCTP mint, then settle()</a:t>
             </a:r>
             <a:endParaRPr lang="en-US" sz="1400" dirty="0"/>
           </a:p>
@@ -3568,6 +3592,10 @@
             <a:prstDash val="solid"/>
           </a:ln>
         </p:spPr>
+        <p:txBody>
+          <a:bodyPr/>
+          <a:p/>
+        </p:txBody>
       </p:sp>
       <p:sp>
         <p:nvSpPr>
@@ -3599,7 +3627,7 @@
                   <a:schemeClr val="tx1"/>
                 </a:solidFill>
               </a:rPr>
-              <a:t>Donor with Gateway</a:t>
+              <a:t>Plain USDC transfer</a:t>
             </a:r>
             <a:endParaRPr lang="en-US" sz="1400" dirty="0"/>
           </a:p>
@@ -3613,7 +3641,7 @@
                   <a:schemeClr val="tx2"/>
                 </a:solidFill>
               </a:rPr>
-              <a:t>Unified Balance Kit spend</a:t>
+              <a:t>Any wallet, then settle()</a:t>
             </a:r>
             <a:endParaRPr lang="en-US" sz="1400" dirty="0"/>
           </a:p>
@@ -3645,6 +3673,10 @@
             <a:prstDash val="solid"/>
           </a:ln>
         </p:spPr>
+        <p:txBody>
+          <a:bodyPr/>
+          <a:p/>
+        </p:txBody>
       </p:sp>
       <p:sp>
         <p:nvSpPr>
@@ -3722,6 +3754,10 @@
             <a:prstDash val="solid"/>
           </a:ln>
         </p:spPr>
+        <p:txBody>
+          <a:bodyPr/>
+          <a:p/>
+        </p:txBody>
       </p:sp>
       <p:sp>
         <p:nvSpPr>
@@ -3799,6 +3835,10 @@
             <a:prstDash val="solid"/>
           </a:ln>
         </p:spPr>
+        <p:txBody>
+          <a:bodyPr/>
+          <a:p/>
+        </p:txBody>
       </p:sp>
       <p:sp>
         <p:nvSpPr>
@@ -3876,6 +3916,10 @@
             <a:prstDash val="solid"/>
           </a:ln>
         </p:spPr>
+        <p:txBody>
+          <a:bodyPr/>
+          <a:p/>
+        </p:txBody>
       </p:sp>
       <p:sp>
         <p:nvSpPr>
@@ -3953,6 +3997,10 @@
             <a:prstDash val="solid"/>
           </a:ln>
         </p:spPr>
+        <p:txBody>
+          <a:bodyPr/>
+          <a:p/>
+        </p:txBody>
       </p:sp>
       <p:sp>
         <p:nvSpPr>
@@ -4027,6 +4075,10 @@
             <a:tailEnd type="triangle"/>
           </a:ln>
         </p:spPr>
+        <p:txBody>
+          <a:bodyPr/>
+          <a:p/>
+        </p:txBody>
       </p:sp>
       <p:sp>
         <p:nvSpPr>
@@ -4051,6 +4103,10 @@
             <a:tailEnd type="triangle"/>
           </a:ln>
         </p:spPr>
+        <p:txBody>
+          <a:bodyPr/>
+          <a:p/>
+        </p:txBody>
       </p:sp>
       <p:sp>
         <p:nvSpPr>
@@ -4075,6 +4131,10 @@
             <a:tailEnd type="triangle"/>
           </a:ln>
         </p:spPr>
+        <p:txBody>
+          <a:bodyPr/>
+          <a:p/>
+        </p:txBody>
       </p:sp>
       <p:sp>
         <p:nvSpPr>
@@ -4099,6 +4159,10 @@
             <a:tailEnd type="triangle"/>
           </a:ln>
         </p:spPr>
+        <p:txBody>
+          <a:bodyPr/>
+          <a:p/>
+        </p:txBody>
       </p:sp>
       <p:sp>
         <p:nvSpPr>
@@ -4123,6 +4187,10 @@
             <a:tailEnd type="triangle"/>
           </a:ln>
         </p:spPr>
+        <p:txBody>
+          <a:bodyPr/>
+          <a:p/>
+        </p:txBody>
       </p:sp>
       <p:sp>
         <p:nvSpPr>
@@ -4147,6 +4215,10 @@
             <a:tailEnd type="triangle"/>
           </a:ln>
         </p:spPr>
+        <p:txBody>
+          <a:bodyPr/>
+          <a:p/>
+        </p:txBody>
       </p:sp>
       <p:sp>
         <p:nvSpPr>
@@ -4171,6 +4243,10 @@
             <a:tailEnd type="triangle"/>
           </a:ln>
         </p:spPr>
+        <p:txBody>
+          <a:bodyPr/>
+          <a:p/>
+        </p:txBody>
       </p:sp>
       <p:sp>
         <p:nvSpPr>
@@ -4202,7 +4278,7 @@
                   <a:schemeClr val="tx2"/>
                 </a:solidFill>
               </a:rPr>
-              <a:t>Dashed: behind the VITE_CROSSCHAIN flag until the live canary passes.</a:t>
+              <a:t>Dashed: arrives without donate(). settle() books it with the same fee.</a:t>
             </a:r>
             <a:endParaRPr lang="en-US" sz="1100" dirty="0"/>
           </a:p>
@@ -4500,7 +4576,7 @@
                           <a:ea typeface="Calibri" pitchFamily="34" charset="-122"/>
                           <a:cs typeface="Calibri" pitchFamily="34" charset="-120"/>
                         </a:rPr>
-                        <a:t>Planned at launch</a:t>
+                        <a:t>Status</a:t>
                       </a:r>
                       <a:endParaRPr lang="en-US" sz="1200" dirty="0">
                         <a:latin typeface="Calibri" charset="0"/>
@@ -4700,7 +4776,7 @@
                           <a:ea typeface="Calibri" pitchFamily="34" charset="-122"/>
                           <a:cs typeface="Calibri" pitchFamily="34" charset="-120"/>
                         </a:rPr>
-                        <a:t>Planned</a:t>
+                        <a:t>Live</a:t>
                       </a:r>
                       <a:endParaRPr lang="en-US" sz="1300" dirty="0">
                         <a:latin typeface="Calibri" charset="0"/>
@@ -4897,204 +4973,7 @@
                           <a:ea typeface="Calibri" pitchFamily="34" charset="-122"/>
                           <a:cs typeface="Calibri" pitchFamily="34" charset="-120"/>
                         </a:rPr>
-                        <a:t>Planned</a:t>
-                      </a:r>
-                      <a:endParaRPr lang="en-US" sz="1300" dirty="0">
-                        <a:latin typeface="Calibri" charset="0"/>
-                        <a:ea typeface="Calibri" charset="0"/>
-                        <a:cs typeface="Calibri" charset="0"/>
-                      </a:endParaRPr>
-                    </a:p>
-                  </a:txBody>
-                  <a:tcPr marL="91440" marR="91440" marT="0" marB="0" anchor="ctr">
-                    <a:lnL w="6350" cap="flat" cmpd="sng" algn="ctr">
-                      <a:solidFill>
-                        <a:srgbClr val="D5DADE"/>
-                      </a:solidFill>
-                      <a:prstDash val="solid"/>
-                      <a:round/>
-                      <a:headEnd type="none" w="med" len="med"/>
-                      <a:tailEnd type="none" w="med" len="med"/>
-                    </a:lnL>
-                    <a:lnR w="6350" cap="flat" cmpd="sng" algn="ctr">
-                      <a:solidFill>
-                        <a:srgbClr val="D5DADE"/>
-                      </a:solidFill>
-                      <a:prstDash val="solid"/>
-                      <a:round/>
-                      <a:headEnd type="none" w="med" len="med"/>
-                      <a:tailEnd type="none" w="med" len="med"/>
-                    </a:lnR>
-                    <a:lnT w="6350" cap="flat" cmpd="sng" algn="ctr">
-                      <a:solidFill>
-                        <a:srgbClr val="D5DADE"/>
-                      </a:solidFill>
-                      <a:prstDash val="solid"/>
-                      <a:round/>
-                      <a:headEnd type="none" w="med" len="med"/>
-                      <a:tailEnd type="none" w="med" len="med"/>
-                    </a:lnT>
-                    <a:lnB w="6350" cap="flat" cmpd="sng" algn="ctr">
-                      <a:solidFill>
-                        <a:srgbClr val="D5DADE"/>
-                      </a:solidFill>
-                      <a:prstDash val="solid"/>
-                      <a:round/>
-                      <a:headEnd type="none" w="med" len="med"/>
-                      <a:tailEnd type="none" w="med" len="med"/>
-                    </a:lnB>
-                  </a:tcPr>
-                </a:tc>
-              </a:tr>
-              <a:tr h="384048">
-                <a:tc>
-                  <a:txBody>
-                    <a:bodyPr/>
-                    <a:lstStyle/>
-                    <a:p>
-                      <a:pPr indent="0" marL="0">
-                        <a:buNone/>
-                      </a:pPr>
-                      <a:r>
-                        <a:rPr lang="en-US" sz="1300" dirty="0">
-                          <a:solidFill>
-                            <a:schemeClr val="tx1"/>
-                          </a:solidFill>
-                          <a:latin typeface="Calibri" pitchFamily="34" charset="0"/>
-                          <a:ea typeface="Calibri" pitchFamily="34" charset="-122"/>
-                          <a:cs typeface="Calibri" pitchFamily="34" charset="-120"/>
-                        </a:rPr>
-                        <a:t>Arc Memo</a:t>
-                      </a:r>
-                      <a:endParaRPr lang="en-US" sz="1300" dirty="0">
-                        <a:latin typeface="Calibri" charset="0"/>
-                        <a:ea typeface="Calibri" charset="0"/>
-                        <a:cs typeface="Calibri" charset="0"/>
-                      </a:endParaRPr>
-                    </a:p>
-                  </a:txBody>
-                  <a:tcPr marL="91440" marR="91440" marT="0" marB="0" anchor="ctr">
-                    <a:lnL w="6350" cap="flat" cmpd="sng" algn="ctr">
-                      <a:solidFill>
-                        <a:srgbClr val="D5DADE"/>
-                      </a:solidFill>
-                      <a:prstDash val="solid"/>
-                      <a:round/>
-                      <a:headEnd type="none" w="med" len="med"/>
-                      <a:tailEnd type="none" w="med" len="med"/>
-                    </a:lnL>
-                    <a:lnR w="6350" cap="flat" cmpd="sng" algn="ctr">
-                      <a:solidFill>
-                        <a:srgbClr val="D5DADE"/>
-                      </a:solidFill>
-                      <a:prstDash val="solid"/>
-                      <a:round/>
-                      <a:headEnd type="none" w="med" len="med"/>
-                      <a:tailEnd type="none" w="med" len="med"/>
-                    </a:lnR>
-                    <a:lnT w="6350" cap="flat" cmpd="sng" algn="ctr">
-                      <a:solidFill>
-                        <a:srgbClr val="D5DADE"/>
-                      </a:solidFill>
-                      <a:prstDash val="solid"/>
-                      <a:round/>
-                      <a:headEnd type="none" w="med" len="med"/>
-                      <a:tailEnd type="none" w="med" len="med"/>
-                    </a:lnT>
-                    <a:lnB w="6350" cap="flat" cmpd="sng" algn="ctr">
-                      <a:solidFill>
-                        <a:srgbClr val="D5DADE"/>
-                      </a:solidFill>
-                      <a:prstDash val="solid"/>
-                      <a:round/>
-                      <a:headEnd type="none" w="med" len="med"/>
-                      <a:tailEnd type="none" w="med" len="med"/>
-                    </a:lnB>
-                  </a:tcPr>
-                </a:tc>
-                <a:tc>
-                  <a:txBody>
-                    <a:bodyPr/>
-                    <a:lstStyle/>
-                    <a:p>
-                      <a:pPr indent="0" marL="0">
-                        <a:buNone/>
-                      </a:pPr>
-                      <a:r>
-                        <a:rPr lang="en-US" sz="1300" dirty="0">
-                          <a:solidFill>
-                            <a:schemeClr val="tx1"/>
-                          </a:solidFill>
-                          <a:latin typeface="Calibri" pitchFamily="34" charset="0"/>
-                          <a:ea typeface="Calibri" pitchFamily="34" charset="-122"/>
-                          <a:cs typeface="Calibri" pitchFamily="34" charset="-120"/>
-                        </a:rPr>
-                        <a:t>Tags each on-Arc donation</a:t>
-                      </a:r>
-                      <a:endParaRPr lang="en-US" sz="1300" dirty="0">
-                        <a:latin typeface="Calibri" charset="0"/>
-                        <a:ea typeface="Calibri" charset="0"/>
-                        <a:cs typeface="Calibri" charset="0"/>
-                      </a:endParaRPr>
-                    </a:p>
-                  </a:txBody>
-                  <a:tcPr marL="91440" marR="91440" marT="0" marB="0" anchor="ctr">
-                    <a:lnL w="6350" cap="flat" cmpd="sng" algn="ctr">
-                      <a:solidFill>
-                        <a:srgbClr val="D5DADE"/>
-                      </a:solidFill>
-                      <a:prstDash val="solid"/>
-                      <a:round/>
-                      <a:headEnd type="none" w="med" len="med"/>
-                      <a:tailEnd type="none" w="med" len="med"/>
-                    </a:lnL>
-                    <a:lnR w="6350" cap="flat" cmpd="sng" algn="ctr">
-                      <a:solidFill>
-                        <a:srgbClr val="D5DADE"/>
-                      </a:solidFill>
-                      <a:prstDash val="solid"/>
-                      <a:round/>
-                      <a:headEnd type="none" w="med" len="med"/>
-                      <a:tailEnd type="none" w="med" len="med"/>
-                    </a:lnR>
-                    <a:lnT w="6350" cap="flat" cmpd="sng" algn="ctr">
-                      <a:solidFill>
-                        <a:srgbClr val="D5DADE"/>
-                      </a:solidFill>
-                      <a:prstDash val="solid"/>
-                      <a:round/>
-                      <a:headEnd type="none" w="med" len="med"/>
-                      <a:tailEnd type="none" w="med" len="med"/>
-                    </a:lnT>
-                    <a:lnB w="6350" cap="flat" cmpd="sng" algn="ctr">
-                      <a:solidFill>
-                        <a:srgbClr val="D5DADE"/>
-                      </a:solidFill>
-                      <a:prstDash val="solid"/>
-                      <a:round/>
-                      <a:headEnd type="none" w="med" len="med"/>
-                      <a:tailEnd type="none" w="med" len="med"/>
-                    </a:lnB>
-                  </a:tcPr>
-                </a:tc>
-                <a:tc>
-                  <a:txBody>
-                    <a:bodyPr/>
-                    <a:lstStyle/>
-                    <a:p>
-                      <a:pPr indent="0" marL="0">
-                        <a:buNone/>
-                      </a:pPr>
-                      <a:r>
-                        <a:rPr lang="en-US" sz="1300" b="1" dirty="0">
-                          <a:solidFill>
-                            <a:schemeClr val="accent2"/>
-                          </a:solidFill>
-                          <a:latin typeface="Calibri" pitchFamily="34" charset="0"/>
-                          <a:ea typeface="Calibri" pitchFamily="34" charset="-122"/>
-                          <a:cs typeface="Calibri" pitchFamily="34" charset="-120"/>
-                        </a:rPr>
-                        <a:t>Planned</a:t>
+                        <a:t>Live</a:t>
                       </a:r>
                       <a:endParaRPr lang="en-US" sz="1300" dirty="0">
                         <a:latin typeface="Calibri" charset="0"/>
@@ -5226,7 +5105,7 @@
                           <a:ea typeface="Calibri" pitchFamily="34" charset="-122"/>
                           <a:cs typeface="Calibri" pitchFamily="34" charset="-120"/>
                         </a:rPr>
-                        <a:t>Creator payouts to six chains</a:t>
+                        <a:t>Payouts and sends to six chains</a:t>
                       </a:r>
                       <a:endParaRPr lang="en-US" sz="1300" dirty="0">
                         <a:latin typeface="Calibri" charset="0"/>
@@ -5291,7 +5170,401 @@
                           <a:ea typeface="Calibri" pitchFamily="34" charset="-122"/>
                           <a:cs typeface="Calibri" pitchFamily="34" charset="-120"/>
                         </a:rPr>
-                        <a:t>Planned</a:t>
+                        <a:t>Live</a:t>
+                      </a:r>
+                      <a:endParaRPr lang="en-US" sz="1300" dirty="0">
+                        <a:latin typeface="Calibri" charset="0"/>
+                        <a:ea typeface="Calibri" charset="0"/>
+                        <a:cs typeface="Calibri" charset="0"/>
+                      </a:endParaRPr>
+                    </a:p>
+                  </a:txBody>
+                  <a:tcPr marL="91440" marR="91440" marT="0" marB="0" anchor="ctr">
+                    <a:lnL w="6350" cap="flat" cmpd="sng" algn="ctr">
+                      <a:solidFill>
+                        <a:srgbClr val="D5DADE"/>
+                      </a:solidFill>
+                      <a:prstDash val="solid"/>
+                      <a:round/>
+                      <a:headEnd type="none" w="med" len="med"/>
+                      <a:tailEnd type="none" w="med" len="med"/>
+                    </a:lnL>
+                    <a:lnR w="6350" cap="flat" cmpd="sng" algn="ctr">
+                      <a:solidFill>
+                        <a:srgbClr val="D5DADE"/>
+                      </a:solidFill>
+                      <a:prstDash val="solid"/>
+                      <a:round/>
+                      <a:headEnd type="none" w="med" len="med"/>
+                      <a:tailEnd type="none" w="med" len="med"/>
+                    </a:lnR>
+                    <a:lnT w="6350" cap="flat" cmpd="sng" algn="ctr">
+                      <a:solidFill>
+                        <a:srgbClr val="D5DADE"/>
+                      </a:solidFill>
+                      <a:prstDash val="solid"/>
+                      <a:round/>
+                      <a:headEnd type="none" w="med" len="med"/>
+                      <a:tailEnd type="none" w="med" len="med"/>
+                    </a:lnT>
+                    <a:lnB w="6350" cap="flat" cmpd="sng" algn="ctr">
+                      <a:solidFill>
+                        <a:srgbClr val="D5DADE"/>
+                      </a:solidFill>
+                      <a:prstDash val="solid"/>
+                      <a:round/>
+                      <a:headEnd type="none" w="med" len="med"/>
+                      <a:tailEnd type="none" w="med" len="med"/>
+                    </a:lnB>
+                  </a:tcPr>
+                </a:tc>
+              </a:tr>
+              <a:tr h="384048">
+                <a:tc>
+                  <a:txBody>
+                    <a:bodyPr/>
+                    <a:lstStyle/>
+                    <a:p>
+                      <a:pPr indent="0" marL="0">
+                        <a:buNone/>
+                      </a:pPr>
+                      <a:r>
+                        <a:rPr lang="en-US" sz="1300" dirty="0">
+                          <a:solidFill>
+                            <a:schemeClr val="tx1"/>
+                          </a:solidFill>
+                          <a:latin typeface="Calibri" pitchFamily="34" charset="0"/>
+                          <a:ea typeface="Calibri" pitchFamily="34" charset="-122"/>
+                          <a:cs typeface="Calibri" pitchFamily="34" charset="-120"/>
+                        </a:rPr>
+                        <a:t>CCTP fees API (Iris)</a:t>
+                      </a:r>
+                      <a:endParaRPr lang="en-US" sz="1300" dirty="0">
+                        <a:latin typeface="Calibri" charset="0"/>
+                        <a:ea typeface="Calibri" charset="0"/>
+                        <a:cs typeface="Calibri" charset="0"/>
+                      </a:endParaRPr>
+                    </a:p>
+                  </a:txBody>
+                  <a:tcPr marL="91440" marR="91440" marT="0" marB="0" anchor="ctr">
+                    <a:lnL w="6350" cap="flat" cmpd="sng" algn="ctr">
+                      <a:solidFill>
+                        <a:srgbClr val="D5DADE"/>
+                      </a:solidFill>
+                      <a:prstDash val="solid"/>
+                      <a:round/>
+                      <a:headEnd type="none" w="med" len="med"/>
+                      <a:tailEnd type="none" w="med" len="med"/>
+                    </a:lnL>
+                    <a:lnR w="6350" cap="flat" cmpd="sng" algn="ctr">
+                      <a:solidFill>
+                        <a:srgbClr val="D5DADE"/>
+                      </a:solidFill>
+                      <a:prstDash val="solid"/>
+                      <a:round/>
+                      <a:headEnd type="none" w="med" len="med"/>
+                      <a:tailEnd type="none" w="med" len="med"/>
+                    </a:lnR>
+                    <a:lnT w="6350" cap="flat" cmpd="sng" algn="ctr">
+                      <a:solidFill>
+                        <a:srgbClr val="D5DADE"/>
+                      </a:solidFill>
+                      <a:prstDash val="solid"/>
+                      <a:round/>
+                      <a:headEnd type="none" w="med" len="med"/>
+                      <a:tailEnd type="none" w="med" len="med"/>
+                    </a:lnT>
+                    <a:lnB w="6350" cap="flat" cmpd="sng" algn="ctr">
+                      <a:solidFill>
+                        <a:srgbClr val="D5DADE"/>
+                      </a:solidFill>
+                      <a:prstDash val="solid"/>
+                      <a:round/>
+                      <a:headEnd type="none" w="med" len="med"/>
+                      <a:tailEnd type="none" w="med" len="med"/>
+                    </a:lnB>
+                  </a:tcPr>
+                </a:tc>
+                <a:tc>
+                  <a:txBody>
+                    <a:bodyPr/>
+                    <a:lstStyle/>
+                    <a:p>
+                      <a:pPr indent="0" marL="0">
+                        <a:buNone/>
+                      </a:pPr>
+                      <a:r>
+                        <a:rPr lang="en-US" sz="1300" dirty="0">
+                          <a:solidFill>
+                            <a:schemeClr val="tx1"/>
+                          </a:solidFill>
+                          <a:latin typeface="Calibri" pitchFamily="34" charset="0"/>
+                          <a:ea typeface="Calibri" pitchFamily="34" charset="-122"/>
+                          <a:cs typeface="Calibri" pitchFamily="34" charset="-120"/>
+                        </a:rPr>
+                        <a:t>Fast and Standard fee quotes</a:t>
+                      </a:r>
+                      <a:endParaRPr lang="en-US" sz="1300" dirty="0">
+                        <a:latin typeface="Calibri" charset="0"/>
+                        <a:ea typeface="Calibri" charset="0"/>
+                        <a:cs typeface="Calibri" charset="0"/>
+                      </a:endParaRPr>
+                    </a:p>
+                  </a:txBody>
+                  <a:tcPr marL="91440" marR="91440" marT="0" marB="0" anchor="ctr">
+                    <a:lnL w="6350" cap="flat" cmpd="sng" algn="ctr">
+                      <a:solidFill>
+                        <a:srgbClr val="D5DADE"/>
+                      </a:solidFill>
+                      <a:prstDash val="solid"/>
+                      <a:round/>
+                      <a:headEnd type="none" w="med" len="med"/>
+                      <a:tailEnd type="none" w="med" len="med"/>
+                    </a:lnL>
+                    <a:lnR w="6350" cap="flat" cmpd="sng" algn="ctr">
+                      <a:solidFill>
+                        <a:srgbClr val="D5DADE"/>
+                      </a:solidFill>
+                      <a:prstDash val="solid"/>
+                      <a:round/>
+                      <a:headEnd type="none" w="med" len="med"/>
+                      <a:tailEnd type="none" w="med" len="med"/>
+                    </a:lnR>
+                    <a:lnT w="6350" cap="flat" cmpd="sng" algn="ctr">
+                      <a:solidFill>
+                        <a:srgbClr val="D5DADE"/>
+                      </a:solidFill>
+                      <a:prstDash val="solid"/>
+                      <a:round/>
+                      <a:headEnd type="none" w="med" len="med"/>
+                      <a:tailEnd type="none" w="med" len="med"/>
+                    </a:lnT>
+                    <a:lnB w="6350" cap="flat" cmpd="sng" algn="ctr">
+                      <a:solidFill>
+                        <a:srgbClr val="D5DADE"/>
+                      </a:solidFill>
+                      <a:prstDash val="solid"/>
+                      <a:round/>
+                      <a:headEnd type="none" w="med" len="med"/>
+                      <a:tailEnd type="none" w="med" len="med"/>
+                    </a:lnB>
+                  </a:tcPr>
+                </a:tc>
+                <a:tc>
+                  <a:txBody>
+                    <a:bodyPr/>
+                    <a:lstStyle/>
+                    <a:p>
+                      <a:pPr indent="0" marL="0">
+                        <a:buNone/>
+                      </a:pPr>
+                      <a:r>
+                        <a:rPr lang="en-US" sz="1300" b="1" dirty="0">
+                          <a:solidFill>
+                            <a:schemeClr val="accent2"/>
+                          </a:solidFill>
+                          <a:latin typeface="Calibri" pitchFamily="34" charset="0"/>
+                          <a:ea typeface="Calibri" pitchFamily="34" charset="-122"/>
+                          <a:cs typeface="Calibri" pitchFamily="34" charset="-120"/>
+                        </a:rPr>
+                        <a:t>Live</a:t>
+                      </a:r>
+                      <a:endParaRPr lang="en-US" sz="1300" dirty="0">
+                        <a:latin typeface="Calibri" charset="0"/>
+                        <a:ea typeface="Calibri" charset="0"/>
+                        <a:cs typeface="Calibri" charset="0"/>
+                      </a:endParaRPr>
+                    </a:p>
+                  </a:txBody>
+                  <a:tcPr marL="91440" marR="91440" marT="0" marB="0" anchor="ctr">
+                    <a:lnL w="6350" cap="flat" cmpd="sng" algn="ctr">
+                      <a:solidFill>
+                        <a:srgbClr val="D5DADE"/>
+                      </a:solidFill>
+                      <a:prstDash val="solid"/>
+                      <a:round/>
+                      <a:headEnd type="none" w="med" len="med"/>
+                      <a:tailEnd type="none" w="med" len="med"/>
+                    </a:lnL>
+                    <a:lnR w="6350" cap="flat" cmpd="sng" algn="ctr">
+                      <a:solidFill>
+                        <a:srgbClr val="D5DADE"/>
+                      </a:solidFill>
+                      <a:prstDash val="solid"/>
+                      <a:round/>
+                      <a:headEnd type="none" w="med" len="med"/>
+                      <a:tailEnd type="none" w="med" len="med"/>
+                    </a:lnR>
+                    <a:lnT w="6350" cap="flat" cmpd="sng" algn="ctr">
+                      <a:solidFill>
+                        <a:srgbClr val="D5DADE"/>
+                      </a:solidFill>
+                      <a:prstDash val="solid"/>
+                      <a:round/>
+                      <a:headEnd type="none" w="med" len="med"/>
+                      <a:tailEnd type="none" w="med" len="med"/>
+                    </a:lnT>
+                    <a:lnB w="6350" cap="flat" cmpd="sng" algn="ctr">
+                      <a:solidFill>
+                        <a:srgbClr val="D5DADE"/>
+                      </a:solidFill>
+                      <a:prstDash val="solid"/>
+                      <a:round/>
+                      <a:headEnd type="none" w="med" len="med"/>
+                      <a:tailEnd type="none" w="med" len="med"/>
+                    </a:lnB>
+                  </a:tcPr>
+                </a:tc>
+              </a:tr>
+              <a:tr h="384048">
+                <a:tc>
+                  <a:txBody>
+                    <a:bodyPr/>
+                    <a:lstStyle/>
+                    <a:p>
+                      <a:pPr indent="0" marL="0">
+                        <a:buNone/>
+                      </a:pPr>
+                      <a:r>
+                        <a:rPr lang="en-US" sz="1300" dirty="0">
+                          <a:solidFill>
+                            <a:schemeClr val="tx1"/>
+                          </a:solidFill>
+                          <a:latin typeface="Calibri" pitchFamily="34" charset="0"/>
+                          <a:ea typeface="Calibri" pitchFamily="34" charset="-122"/>
+                          <a:cs typeface="Calibri" pitchFamily="34" charset="-120"/>
+                        </a:rPr>
+                        <a:t>Modular Wallets</a:t>
+                      </a:r>
+                      <a:endParaRPr lang="en-US" sz="1300" dirty="0">
+                        <a:latin typeface="Calibri" charset="0"/>
+                        <a:ea typeface="Calibri" charset="0"/>
+                        <a:cs typeface="Calibri" charset="0"/>
+                      </a:endParaRPr>
+                    </a:p>
+                  </a:txBody>
+                  <a:tcPr marL="91440" marR="91440" marT="0" marB="0" anchor="ctr">
+                    <a:lnL w="6350" cap="flat" cmpd="sng" algn="ctr">
+                      <a:solidFill>
+                        <a:srgbClr val="D5DADE"/>
+                      </a:solidFill>
+                      <a:prstDash val="solid"/>
+                      <a:round/>
+                      <a:headEnd type="none" w="med" len="med"/>
+                      <a:tailEnd type="none" w="med" len="med"/>
+                    </a:lnL>
+                    <a:lnR w="6350" cap="flat" cmpd="sng" algn="ctr">
+                      <a:solidFill>
+                        <a:srgbClr val="D5DADE"/>
+                      </a:solidFill>
+                      <a:prstDash val="solid"/>
+                      <a:round/>
+                      <a:headEnd type="none" w="med" len="med"/>
+                      <a:tailEnd type="none" w="med" len="med"/>
+                    </a:lnR>
+                    <a:lnT w="6350" cap="flat" cmpd="sng" algn="ctr">
+                      <a:solidFill>
+                        <a:srgbClr val="D5DADE"/>
+                      </a:solidFill>
+                      <a:prstDash val="solid"/>
+                      <a:round/>
+                      <a:headEnd type="none" w="med" len="med"/>
+                      <a:tailEnd type="none" w="med" len="med"/>
+                    </a:lnT>
+                    <a:lnB w="6350" cap="flat" cmpd="sng" algn="ctr">
+                      <a:solidFill>
+                        <a:srgbClr val="D5DADE"/>
+                      </a:solidFill>
+                      <a:prstDash val="solid"/>
+                      <a:round/>
+                      <a:headEnd type="none" w="med" len="med"/>
+                      <a:tailEnd type="none" w="med" len="med"/>
+                    </a:lnB>
+                  </a:tcPr>
+                </a:tc>
+                <a:tc>
+                  <a:txBody>
+                    <a:bodyPr/>
+                    <a:lstStyle/>
+                    <a:p>
+                      <a:pPr indent="0" marL="0">
+                        <a:buNone/>
+                      </a:pPr>
+                      <a:r>
+                        <a:rPr lang="en-US" sz="1300" dirty="0">
+                          <a:solidFill>
+                            <a:schemeClr val="tx1"/>
+                          </a:solidFill>
+                          <a:latin typeface="Calibri" pitchFamily="34" charset="0"/>
+                          <a:ea typeface="Calibri" pitchFamily="34" charset="-122"/>
+                          <a:cs typeface="Calibri" pitchFamily="34" charset="-120"/>
+                        </a:rPr>
+                        <a:t>Fundit accounts, passkey-only sign-in</a:t>
+                      </a:r>
+                      <a:endParaRPr lang="en-US" sz="1300" dirty="0">
+                        <a:latin typeface="Calibri" charset="0"/>
+                        <a:ea typeface="Calibri" charset="0"/>
+                        <a:cs typeface="Calibri" charset="0"/>
+                      </a:endParaRPr>
+                    </a:p>
+                  </a:txBody>
+                  <a:tcPr marL="91440" marR="91440" marT="0" marB="0" anchor="ctr">
+                    <a:lnL w="6350" cap="flat" cmpd="sng" algn="ctr">
+                      <a:solidFill>
+                        <a:srgbClr val="D5DADE"/>
+                      </a:solidFill>
+                      <a:prstDash val="solid"/>
+                      <a:round/>
+                      <a:headEnd type="none" w="med" len="med"/>
+                      <a:tailEnd type="none" w="med" len="med"/>
+                    </a:lnL>
+                    <a:lnR w="6350" cap="flat" cmpd="sng" algn="ctr">
+                      <a:solidFill>
+                        <a:srgbClr val="D5DADE"/>
+                      </a:solidFill>
+                      <a:prstDash val="solid"/>
+                      <a:round/>
+                      <a:headEnd type="none" w="med" len="med"/>
+                      <a:tailEnd type="none" w="med" len="med"/>
+                    </a:lnR>
+                    <a:lnT w="6350" cap="flat" cmpd="sng" algn="ctr">
+                      <a:solidFill>
+                        <a:srgbClr val="D5DADE"/>
+                      </a:solidFill>
+                      <a:prstDash val="solid"/>
+                      <a:round/>
+                      <a:headEnd type="none" w="med" len="med"/>
+                      <a:tailEnd type="none" w="med" len="med"/>
+                    </a:lnT>
+                    <a:lnB w="6350" cap="flat" cmpd="sng" algn="ctr">
+                      <a:solidFill>
+                        <a:srgbClr val="D5DADE"/>
+                      </a:solidFill>
+                      <a:prstDash val="solid"/>
+                      <a:round/>
+                      <a:headEnd type="none" w="med" len="med"/>
+                      <a:tailEnd type="none" w="med" len="med"/>
+                    </a:lnB>
+                  </a:tcPr>
+                </a:tc>
+                <a:tc>
+                  <a:txBody>
+                    <a:bodyPr/>
+                    <a:lstStyle/>
+                    <a:p>
+                      <a:pPr indent="0" marL="0">
+                        <a:buNone/>
+                      </a:pPr>
+                      <a:r>
+                        <a:rPr lang="en-US" sz="1300" b="1" dirty="0">
+                          <a:solidFill>
+                            <a:schemeClr val="accent1"/>
+                          </a:solidFill>
+                          <a:latin typeface="Calibri" pitchFamily="34" charset="0"/>
+                          <a:ea typeface="Calibri" pitchFamily="34" charset="-122"/>
+                          <a:cs typeface="Calibri" pitchFamily="34" charset="-120"/>
+                        </a:rPr>
+                        <a:t>Next release</a:t>
                       </a:r>
                       <a:endParaRPr lang="en-US" sz="1300" dirty="0">
                         <a:latin typeface="Calibri" charset="0"/>
@@ -5423,401 +5696,7 @@
                           <a:ea typeface="Calibri" pitchFamily="34" charset="-122"/>
                           <a:cs typeface="Calibri" pitchFamily="34" charset="-120"/>
                         </a:rPr>
-                        <a:t>Donations from other chains</a:t>
-                      </a:r>
-                      <a:endParaRPr lang="en-US" sz="1300" dirty="0">
-                        <a:latin typeface="Calibri" charset="0"/>
-                        <a:ea typeface="Calibri" charset="0"/>
-                        <a:cs typeface="Calibri" charset="0"/>
-                      </a:endParaRPr>
-                    </a:p>
-                  </a:txBody>
-                  <a:tcPr marL="91440" marR="91440" marT="0" marB="0" anchor="ctr">
-                    <a:lnL w="6350" cap="flat" cmpd="sng" algn="ctr">
-                      <a:solidFill>
-                        <a:srgbClr val="D5DADE"/>
-                      </a:solidFill>
-                      <a:prstDash val="solid"/>
-                      <a:round/>
-                      <a:headEnd type="none" w="med" len="med"/>
-                      <a:tailEnd type="none" w="med" len="med"/>
-                    </a:lnL>
-                    <a:lnR w="6350" cap="flat" cmpd="sng" algn="ctr">
-                      <a:solidFill>
-                        <a:srgbClr val="D5DADE"/>
-                      </a:solidFill>
-                      <a:prstDash val="solid"/>
-                      <a:round/>
-                      <a:headEnd type="none" w="med" len="med"/>
-                      <a:tailEnd type="none" w="med" len="med"/>
-                    </a:lnR>
-                    <a:lnT w="6350" cap="flat" cmpd="sng" algn="ctr">
-                      <a:solidFill>
-                        <a:srgbClr val="D5DADE"/>
-                      </a:solidFill>
-                      <a:prstDash val="solid"/>
-                      <a:round/>
-                      <a:headEnd type="none" w="med" len="med"/>
-                      <a:tailEnd type="none" w="med" len="med"/>
-                    </a:lnT>
-                    <a:lnB w="6350" cap="flat" cmpd="sng" algn="ctr">
-                      <a:solidFill>
-                        <a:srgbClr val="D5DADE"/>
-                      </a:solidFill>
-                      <a:prstDash val="solid"/>
-                      <a:round/>
-                      <a:headEnd type="none" w="med" len="med"/>
-                      <a:tailEnd type="none" w="med" len="med"/>
-                    </a:lnB>
-                  </a:tcPr>
-                </a:tc>
-                <a:tc>
-                  <a:txBody>
-                    <a:bodyPr/>
-                    <a:lstStyle/>
-                    <a:p>
-                      <a:pPr indent="0" marL="0">
-                        <a:buNone/>
-                      </a:pPr>
-                      <a:r>
-                        <a:rPr lang="en-US" sz="1300" b="1" dirty="0">
-                          <a:solidFill>
-                            <a:schemeClr val="accent1"/>
-                          </a:solidFill>
-                          <a:latin typeface="Calibri" pitchFamily="34" charset="0"/>
-                          <a:ea typeface="Calibri" pitchFamily="34" charset="-122"/>
-                          <a:cs typeface="Calibri" pitchFamily="34" charset="-120"/>
-                        </a:rPr>
-                        <a:t>Behind a flag</a:t>
-                      </a:r>
-                      <a:endParaRPr lang="en-US" sz="1300" dirty="0">
-                        <a:latin typeface="Calibri" charset="0"/>
-                        <a:ea typeface="Calibri" charset="0"/>
-                        <a:cs typeface="Calibri" charset="0"/>
-                      </a:endParaRPr>
-                    </a:p>
-                  </a:txBody>
-                  <a:tcPr marL="91440" marR="91440" marT="0" marB="0" anchor="ctr">
-                    <a:lnL w="6350" cap="flat" cmpd="sng" algn="ctr">
-                      <a:solidFill>
-                        <a:srgbClr val="D5DADE"/>
-                      </a:solidFill>
-                      <a:prstDash val="solid"/>
-                      <a:round/>
-                      <a:headEnd type="none" w="med" len="med"/>
-                      <a:tailEnd type="none" w="med" len="med"/>
-                    </a:lnL>
-                    <a:lnR w="6350" cap="flat" cmpd="sng" algn="ctr">
-                      <a:solidFill>
-                        <a:srgbClr val="D5DADE"/>
-                      </a:solidFill>
-                      <a:prstDash val="solid"/>
-                      <a:round/>
-                      <a:headEnd type="none" w="med" len="med"/>
-                      <a:tailEnd type="none" w="med" len="med"/>
-                    </a:lnR>
-                    <a:lnT w="6350" cap="flat" cmpd="sng" algn="ctr">
-                      <a:solidFill>
-                        <a:srgbClr val="D5DADE"/>
-                      </a:solidFill>
-                      <a:prstDash val="solid"/>
-                      <a:round/>
-                      <a:headEnd type="none" w="med" len="med"/>
-                      <a:tailEnd type="none" w="med" len="med"/>
-                    </a:lnT>
-                    <a:lnB w="6350" cap="flat" cmpd="sng" algn="ctr">
-                      <a:solidFill>
-                        <a:srgbClr val="D5DADE"/>
-                      </a:solidFill>
-                      <a:prstDash val="solid"/>
-                      <a:round/>
-                      <a:headEnd type="none" w="med" len="med"/>
-                      <a:tailEnd type="none" w="med" len="med"/>
-                    </a:lnB>
-                  </a:tcPr>
-                </a:tc>
-              </a:tr>
-              <a:tr h="384048">
-                <a:tc>
-                  <a:txBody>
-                    <a:bodyPr/>
-                    <a:lstStyle/>
-                    <a:p>
-                      <a:pPr indent="0" marL="0">
-                        <a:buNone/>
-                      </a:pPr>
-                      <a:r>
-                        <a:rPr lang="en-US" sz="1300" dirty="0">
-                          <a:solidFill>
-                            <a:schemeClr val="tx1"/>
-                          </a:solidFill>
-                          <a:latin typeface="Calibri" pitchFamily="34" charset="0"/>
-                          <a:ea typeface="Calibri" pitchFamily="34" charset="-122"/>
-                          <a:cs typeface="Calibri" pitchFamily="34" charset="-120"/>
-                        </a:rPr>
-                        <a:t>Gateway and Unified Balance Kit</a:t>
-                      </a:r>
-                      <a:endParaRPr lang="en-US" sz="1300" dirty="0">
-                        <a:latin typeface="Calibri" charset="0"/>
-                        <a:ea typeface="Calibri" charset="0"/>
-                        <a:cs typeface="Calibri" charset="0"/>
-                      </a:endParaRPr>
-                    </a:p>
-                  </a:txBody>
-                  <a:tcPr marL="91440" marR="91440" marT="0" marB="0" anchor="ctr">
-                    <a:lnL w="6350" cap="flat" cmpd="sng" algn="ctr">
-                      <a:solidFill>
-                        <a:srgbClr val="D5DADE"/>
-                      </a:solidFill>
-                      <a:prstDash val="solid"/>
-                      <a:round/>
-                      <a:headEnd type="none" w="med" len="med"/>
-                      <a:tailEnd type="none" w="med" len="med"/>
-                    </a:lnL>
-                    <a:lnR w="6350" cap="flat" cmpd="sng" algn="ctr">
-                      <a:solidFill>
-                        <a:srgbClr val="D5DADE"/>
-                      </a:solidFill>
-                      <a:prstDash val="solid"/>
-                      <a:round/>
-                      <a:headEnd type="none" w="med" len="med"/>
-                      <a:tailEnd type="none" w="med" len="med"/>
-                    </a:lnR>
-                    <a:lnT w="6350" cap="flat" cmpd="sng" algn="ctr">
-                      <a:solidFill>
-                        <a:srgbClr val="D5DADE"/>
-                      </a:solidFill>
-                      <a:prstDash val="solid"/>
-                      <a:round/>
-                      <a:headEnd type="none" w="med" len="med"/>
-                      <a:tailEnd type="none" w="med" len="med"/>
-                    </a:lnT>
-                    <a:lnB w="6350" cap="flat" cmpd="sng" algn="ctr">
-                      <a:solidFill>
-                        <a:srgbClr val="D5DADE"/>
-                      </a:solidFill>
-                      <a:prstDash val="solid"/>
-                      <a:round/>
-                      <a:headEnd type="none" w="med" len="med"/>
-                      <a:tailEnd type="none" w="med" len="med"/>
-                    </a:lnB>
-                  </a:tcPr>
-                </a:tc>
-                <a:tc>
-                  <a:txBody>
-                    <a:bodyPr/>
-                    <a:lstStyle/>
-                    <a:p>
-                      <a:pPr indent="0" marL="0">
-                        <a:buNone/>
-                      </a:pPr>
-                      <a:r>
-                        <a:rPr lang="en-US" sz="1300" dirty="0">
-                          <a:solidFill>
-                            <a:schemeClr val="tx1"/>
-                          </a:solidFill>
-                          <a:latin typeface="Calibri" pitchFamily="34" charset="0"/>
-                          <a:ea typeface="Calibri" pitchFamily="34" charset="-122"/>
-                          <a:cs typeface="Calibri" pitchFamily="34" charset="-120"/>
-                        </a:rPr>
-                        <a:t>Donations from a unified balance</a:t>
-                      </a:r>
-                      <a:endParaRPr lang="en-US" sz="1300" dirty="0">
-                        <a:latin typeface="Calibri" charset="0"/>
-                        <a:ea typeface="Calibri" charset="0"/>
-                        <a:cs typeface="Calibri" charset="0"/>
-                      </a:endParaRPr>
-                    </a:p>
-                  </a:txBody>
-                  <a:tcPr marL="91440" marR="91440" marT="0" marB="0" anchor="ctr">
-                    <a:lnL w="6350" cap="flat" cmpd="sng" algn="ctr">
-                      <a:solidFill>
-                        <a:srgbClr val="D5DADE"/>
-                      </a:solidFill>
-                      <a:prstDash val="solid"/>
-                      <a:round/>
-                      <a:headEnd type="none" w="med" len="med"/>
-                      <a:tailEnd type="none" w="med" len="med"/>
-                    </a:lnL>
-                    <a:lnR w="6350" cap="flat" cmpd="sng" algn="ctr">
-                      <a:solidFill>
-                        <a:srgbClr val="D5DADE"/>
-                      </a:solidFill>
-                      <a:prstDash val="solid"/>
-                      <a:round/>
-                      <a:headEnd type="none" w="med" len="med"/>
-                      <a:tailEnd type="none" w="med" len="med"/>
-                    </a:lnR>
-                    <a:lnT w="6350" cap="flat" cmpd="sng" algn="ctr">
-                      <a:solidFill>
-                        <a:srgbClr val="D5DADE"/>
-                      </a:solidFill>
-                      <a:prstDash val="solid"/>
-                      <a:round/>
-                      <a:headEnd type="none" w="med" len="med"/>
-                      <a:tailEnd type="none" w="med" len="med"/>
-                    </a:lnT>
-                    <a:lnB w="6350" cap="flat" cmpd="sng" algn="ctr">
-                      <a:solidFill>
-                        <a:srgbClr val="D5DADE"/>
-                      </a:solidFill>
-                      <a:prstDash val="solid"/>
-                      <a:round/>
-                      <a:headEnd type="none" w="med" len="med"/>
-                      <a:tailEnd type="none" w="med" len="med"/>
-                    </a:lnB>
-                  </a:tcPr>
-                </a:tc>
-                <a:tc>
-                  <a:txBody>
-                    <a:bodyPr/>
-                    <a:lstStyle/>
-                    <a:p>
-                      <a:pPr indent="0" marL="0">
-                        <a:buNone/>
-                      </a:pPr>
-                      <a:r>
-                        <a:rPr lang="en-US" sz="1300" b="1" dirty="0">
-                          <a:solidFill>
-                            <a:schemeClr val="accent1"/>
-                          </a:solidFill>
-                          <a:latin typeface="Calibri" pitchFamily="34" charset="0"/>
-                          <a:ea typeface="Calibri" pitchFamily="34" charset="-122"/>
-                          <a:cs typeface="Calibri" pitchFamily="34" charset="-120"/>
-                        </a:rPr>
-                        <a:t>Behind a flag</a:t>
-                      </a:r>
-                      <a:endParaRPr lang="en-US" sz="1300" dirty="0">
-                        <a:latin typeface="Calibri" charset="0"/>
-                        <a:ea typeface="Calibri" charset="0"/>
-                        <a:cs typeface="Calibri" charset="0"/>
-                      </a:endParaRPr>
-                    </a:p>
-                  </a:txBody>
-                  <a:tcPr marL="91440" marR="91440" marT="0" marB="0" anchor="ctr">
-                    <a:lnL w="6350" cap="flat" cmpd="sng" algn="ctr">
-                      <a:solidFill>
-                        <a:srgbClr val="D5DADE"/>
-                      </a:solidFill>
-                      <a:prstDash val="solid"/>
-                      <a:round/>
-                      <a:headEnd type="none" w="med" len="med"/>
-                      <a:tailEnd type="none" w="med" len="med"/>
-                    </a:lnL>
-                    <a:lnR w="6350" cap="flat" cmpd="sng" algn="ctr">
-                      <a:solidFill>
-                        <a:srgbClr val="D5DADE"/>
-                      </a:solidFill>
-                      <a:prstDash val="solid"/>
-                      <a:round/>
-                      <a:headEnd type="none" w="med" len="med"/>
-                      <a:tailEnd type="none" w="med" len="med"/>
-                    </a:lnR>
-                    <a:lnT w="6350" cap="flat" cmpd="sng" algn="ctr">
-                      <a:solidFill>
-                        <a:srgbClr val="D5DADE"/>
-                      </a:solidFill>
-                      <a:prstDash val="solid"/>
-                      <a:round/>
-                      <a:headEnd type="none" w="med" len="med"/>
-                      <a:tailEnd type="none" w="med" len="med"/>
-                    </a:lnT>
-                    <a:lnB w="6350" cap="flat" cmpd="sng" algn="ctr">
-                      <a:solidFill>
-                        <a:srgbClr val="D5DADE"/>
-                      </a:solidFill>
-                      <a:prstDash val="solid"/>
-                      <a:round/>
-                      <a:headEnd type="none" w="med" len="med"/>
-                      <a:tailEnd type="none" w="med" len="med"/>
-                    </a:lnB>
-                  </a:tcPr>
-                </a:tc>
-              </a:tr>
-              <a:tr h="384048">
-                <a:tc>
-                  <a:txBody>
-                    <a:bodyPr/>
-                    <a:lstStyle/>
-                    <a:p>
-                      <a:pPr indent="0" marL="0">
-                        <a:buNone/>
-                      </a:pPr>
-                      <a:r>
-                        <a:rPr lang="en-US" sz="1300" dirty="0">
-                          <a:solidFill>
-                            <a:schemeClr val="tx1"/>
-                          </a:solidFill>
-                          <a:latin typeface="Calibri" pitchFamily="34" charset="0"/>
-                          <a:ea typeface="Calibri" pitchFamily="34" charset="-122"/>
-                          <a:cs typeface="Calibri" pitchFamily="34" charset="-120"/>
-                        </a:rPr>
-                        <a:t>Modular Wallets</a:t>
-                      </a:r>
-                      <a:endParaRPr lang="en-US" sz="1300" dirty="0">
-                        <a:latin typeface="Calibri" charset="0"/>
-                        <a:ea typeface="Calibri" charset="0"/>
-                        <a:cs typeface="Calibri" charset="0"/>
-                      </a:endParaRPr>
-                    </a:p>
-                  </a:txBody>
-                  <a:tcPr marL="91440" marR="91440" marT="0" marB="0" anchor="ctr">
-                    <a:lnL w="6350" cap="flat" cmpd="sng" algn="ctr">
-                      <a:solidFill>
-                        <a:srgbClr val="D5DADE"/>
-                      </a:solidFill>
-                      <a:prstDash val="solid"/>
-                      <a:round/>
-                      <a:headEnd type="none" w="med" len="med"/>
-                      <a:tailEnd type="none" w="med" len="med"/>
-                    </a:lnL>
-                    <a:lnR w="6350" cap="flat" cmpd="sng" algn="ctr">
-                      <a:solidFill>
-                        <a:srgbClr val="D5DADE"/>
-                      </a:solidFill>
-                      <a:prstDash val="solid"/>
-                      <a:round/>
-                      <a:headEnd type="none" w="med" len="med"/>
-                      <a:tailEnd type="none" w="med" len="med"/>
-                    </a:lnR>
-                    <a:lnT w="6350" cap="flat" cmpd="sng" algn="ctr">
-                      <a:solidFill>
-                        <a:srgbClr val="D5DADE"/>
-                      </a:solidFill>
-                      <a:prstDash val="solid"/>
-                      <a:round/>
-                      <a:headEnd type="none" w="med" len="med"/>
-                      <a:tailEnd type="none" w="med" len="med"/>
-                    </a:lnT>
-                    <a:lnB w="6350" cap="flat" cmpd="sng" algn="ctr">
-                      <a:solidFill>
-                        <a:srgbClr val="D5DADE"/>
-                      </a:solidFill>
-                      <a:prstDash val="solid"/>
-                      <a:round/>
-                      <a:headEnd type="none" w="med" len="med"/>
-                      <a:tailEnd type="none" w="med" len="med"/>
-                    </a:lnB>
-                  </a:tcPr>
-                </a:tc>
-                <a:tc>
-                  <a:txBody>
-                    <a:bodyPr/>
-                    <a:lstStyle/>
-                    <a:p>
-                      <a:pPr indent="0" marL="0">
-                        <a:buNone/>
-                      </a:pPr>
-                      <a:r>
-                        <a:rPr lang="en-US" sz="1300" dirty="0">
-                          <a:solidFill>
-                            <a:schemeClr val="tx1"/>
-                          </a:solidFill>
-                          <a:latin typeface="Calibri" pitchFamily="34" charset="0"/>
-                          <a:ea typeface="Calibri" pitchFamily="34" charset="-122"/>
-                          <a:cs typeface="Calibri" pitchFamily="34" charset="-120"/>
-                        </a:rPr>
-                        <a:t>Passkey accounts for new users</a:t>
+                        <a:t>Add money from other chains</a:t>
                       </a:r>
                       <a:endParaRPr lang="en-US" sz="1300" dirty="0">
                         <a:latin typeface="Calibri" charset="0"/>
@@ -6709,7 +6588,7 @@
                   <a:schemeClr val="tx2"/>
                 </a:solidFill>
               </a:rPr>
-              <a:t>Fees are copied into each campaign when it is created and never change for that campaign. Donors can add an optional tip. Fundit will run as a static site on free hosting, so there is no infrastructure bill.</a:t>
+              <a:t>Fees are copied into each campaign when it is created and never change for that campaign. Donors can add an optional tip. Fundit runs as a static site on free hosting, so there is no infrastructure bill.</a:t>
             </a:r>
             <a:endParaRPr lang="en-US" sz="1400" dirty="0"/>
           </a:p>
@@ -6852,6 +6731,10 @@
             <a:prstDash val="solid"/>
           </a:ln>
         </p:spPr>
+        <p:txBody>
+          <a:bodyPr/>
+          <a:p/>
+        </p:txBody>
       </p:sp>
       <p:sp>
         <p:nvSpPr>
@@ -6919,7 +6802,7 @@
                   <a:schemeClr val="tx1"/>
                 </a:solidFill>
               </a:rPr>
-              <a:t>Unit, fuzz, invariant and Arc mainnet fork tests. Slither findings documented. Playwright e2e on a fork.</a:t>
+              <a:t>Unit, fuzz, invariant and Arc mainnet fork tests. Slither findings documented. Money tests run on Arc testnet.</a:t>
             </a:r>
             <a:endParaRPr lang="en-US" sz="1400" dirty="0"/>
           </a:p>
@@ -6951,6 +6834,10 @@
             <a:prstDash val="solid"/>
           </a:ln>
         </p:spPr>
+        <p:txBody>
+          <a:bodyPr/>
+          <a:p/>
+        </p:txBody>
       </p:sp>
       <p:sp>
         <p:nvSpPr>
@@ -6982,7 +6869,7 @@
                   <a:schemeClr val="accent1"/>
                 </a:solidFill>
               </a:rPr>
-              <a:t>Not deployed yet</a:t>
+              <a:t>Live on Arc mainnet</a:t>
             </a:r>
             <a:endParaRPr lang="en-US" sz="1600" dirty="0"/>
           </a:p>
@@ -7018,7 +6905,7 @@
                   <a:schemeClr val="tx1"/>
                 </a:solidFill>
               </a:rPr>
-              <a:t>Contracts and app deploy next, then a canary of about 5 USDC on mainnet.</a:t>
+              <a:t>Factory 0xf1b2AEF8...17d9 and implementation 0x083CE7a6...3853, verified on Sourcify. fundit.fun is live.</a:t>
             </a:r>
             <a:endParaRPr lang="en-US" sz="1400" dirty="0"/>
           </a:p>
@@ -7050,6 +6937,10 @@
             <a:prstDash val="solid"/>
           </a:ln>
         </p:spPr>
+        <p:txBody>
+          <a:bodyPr/>
+          <a:p/>
+        </p:txBody>
       </p:sp>
       <p:sp>
         <p:nvSpPr>
@@ -7081,7 +6972,7 @@
                   <a:schemeClr val="tx1"/>
                 </a:solidFill>
               </a:rPr>
-              <a:t>Behind flags</a:t>
+              <a:t>Passkey sign-in next</a:t>
             </a:r>
             <a:endParaRPr lang="en-US" sz="1600" dirty="0"/>
           </a:p>
@@ -7117,7 +7008,7 @@
                   <a:schemeClr val="tx1"/>
                 </a:solidFill>
               </a:rPr>
-              <a:t>Cross-chain donations, unified balance donations and passkeys are unit-tested with mocks. They turn on only after the live canary confirms each.</a:t>
+              <a:t>Sign-in becomes passkey only: a Fundit account on Arc. Add money from other chains stays behind a flag.</a:t>
             </a:r>
             <a:endParaRPr lang="en-US" sz="1400" dirty="0"/>
           </a:p>
@@ -7149,6 +7040,10 @@
             <a:prstDash val="solid"/>
           </a:ln>
         </p:spPr>
+        <p:txBody>
+          <a:bodyPr/>
+          <a:p/>
+        </p:txBody>
       </p:sp>
       <p:sp>
         <p:nvSpPr>
@@ -7355,6 +7250,10 @@
             <a:prstDash val="solid"/>
           </a:ln>
         </p:spPr>
+        <p:txBody>
+          <a:bodyPr/>
+          <a:p/>
+        </p:txBody>
       </p:sp>
       <p:sp>
         <p:nvSpPr>
@@ -7380,6 +7279,10 @@
             <a:prstDash val="solid"/>
           </a:ln>
         </p:spPr>
+        <p:txBody>
+          <a:bodyPr/>
+          <a:p/>
+        </p:txBody>
       </p:sp>
       <p:sp>
         <p:nvSpPr>
@@ -7511,7 +7414,7 @@
                   <a:schemeClr val="tx1"/>
                 </a:solidFill>
               </a:rPr>
-              <a:t>Verified factory, live app, canary done</a:t>
+              <a:t>Factory and app live, passkey sign-in released</a:t>
             </a:r>
             <a:endParaRPr lang="en-US" sz="1400" dirty="0"/>
           </a:p>
@@ -7541,6 +7444,10 @@
             <a:prstDash val="solid"/>
           </a:ln>
         </p:spPr>
+        <p:txBody>
+          <a:bodyPr/>
+          <a:p/>
+        </p:txBody>
       </p:sp>
       <p:sp>
         <p:nvSpPr>
@@ -7636,7 +7543,7 @@
                   <a:schemeClr val="tx1"/>
                 </a:solidFill>
               </a:rPr>
-              <a:t>Flags on</a:t>
+              <a:t>Cross-chain</a:t>
             </a:r>
             <a:endParaRPr lang="en-US" sz="1500" dirty="0"/>
           </a:p>
@@ -7672,7 +7579,7 @@
                   <a:schemeClr val="tx1"/>
                 </a:solidFill>
               </a:rPr>
-              <a:t>Cross-chain donations and passkeys live</a:t>
+              <a:t>Add money from other chains, after testnet checks</a:t>
             </a:r>
             <a:endParaRPr lang="en-US" sz="1400" dirty="0"/>
           </a:p>
@@ -7702,6 +7609,10 @@
             <a:prstDash val="solid"/>
           </a:ln>
         </p:spPr>
+        <p:txBody>
+          <a:bodyPr/>
+          <a:p/>
+        </p:txBody>
       </p:sp>
       <p:sp>
         <p:nvSpPr>
@@ -7863,6 +7774,10 @@
             <a:prstDash val="solid"/>
           </a:ln>
         </p:spPr>
+        <p:txBody>
+          <a:bodyPr/>
+          <a:p/>
+        </p:txBody>
       </p:sp>
       <p:sp>
         <p:nvSpPr>
@@ -8024,6 +7939,10 @@
             <a:prstDash val="solid"/>
           </a:ln>
         </p:spPr>
+        <p:txBody>
+          <a:bodyPr/>
+          <a:p/>
+        </p:txBody>
       </p:sp>
       <p:sp>
         <p:nvSpPr>

</xml_diff>

<commit_message>
docs: fix deck notes, testnet wording and whitepaper status list
</commit_message>
<xml_diff>
--- a/docs/fundit-pitch-deck.pptx
+++ b/docs/fundit-pitch-deck.pptx
@@ -822,7 +822,7 @@
           <a:p>
             <a:r>
               <a:rPr lang="en-US" dirty="0"/>
-              <a:t>0:30 to 1:45. Only after the mainnet deploy; before then, demo the fork build. Demo path: create a campaign, donate 1 USDC with a tip and message, show the activity list and explorer link, then withdraw to Base (only after canary C4 passes).</a:t>
+              <a:t>0:30 to 1:45. Demo on an Arc testnet build. Testnet testing is set up, and the testnet factory deploy is pending, so the demo waits for it. Demo path: sign in with a passkey, save the recovery key, add money, create a Fundit, give 1 USDC with a tip and a message, show the activity list and explorer link, then withdraw to Base Sepolia.</a:t>
             </a:r>
             <a:endParaRPr lang="en-US" dirty="0"/>
           </a:p>
@@ -910,7 +910,7 @@
           <a:p>
             <a:r>
               <a:rPr lang="en-US" dirty="0"/>
-              <a:t>Walk the money: three donor paths in, one escrow, payouts out. The owner has no path to a creator balance. Treasury rotation only affects where unclaimed fees go.</a:t>
+              <a:t>Walk the money: the donor's Fundit account gives through donate(). Any USDC that arrives without donate() is booked by settle() with the same fee. One escrow, payouts out. The owner has no path to a creator balance. Treasury rotation only affects where unclaimed fees go.</a:t>
             </a:r>
             <a:endParaRPr lang="en-US" dirty="0"/>
           </a:p>
@@ -998,7 +998,7 @@
           <a:p>
             <a:r>
               <a:rPr lang="en-US" dirty="0"/>
-              <a:t>1:45 to 2:30. Four products are planned for launch, pending canary steps C2 and C4. Cross-chain donations, unified balance donations and passkeys are built and unit-tested with mocks. On an Arc mainnet fork, the end-to-end suite simulates a forwarded mint (a plain USDC transfer and a stubbed Iris response). No Bridge Kit, Gateway or Modular Wallets call has run against Arc yet. They stay off until the live canary confirms them.</a:t>
+              <a:t>1:45 to 2:30. Arc, USDC and EURC, CCTP V2 with the Forwarding Service, and the Iris fees API work with the mainnet contracts today. Modular Wallets, with passkey-only sign-in, ships in the next release. Bridge Kit, for adding money from other chains, stays behind a flag.</a:t>
             </a:r>
             <a:endParaRPr lang="en-US" dirty="0"/>
           </a:p>
@@ -1262,7 +1262,7 @@
           <a:p>
             <a:r>
               <a:rPr lang="en-US" dirty="0"/>
-              <a:t>3:15 to 3:45. Pre-launch. No traction numbers yet. Every number we report later comes from on-chain data.</a:t>
+              <a:t>3:15 to 3:45. Contracts live on Arc mainnet. Testnet testing is set up, and the testnet factory deploy is pending. No traction numbers yet. Every number we report later comes from on-chain data.</a:t>
             </a:r>
             <a:endParaRPr lang="en-US" dirty="0"/>
           </a:p>
@@ -3150,7 +3150,7 @@
                   <a:schemeClr val="tx1"/>
                 </a:solidFill>
               </a:rPr>
-              <a:t>USDC minted in from other chains is booked by settle() and pays the same fee.</a:t>
+              <a:t>Any USDC that arrives without donate() is booked by settle() and pays the same fee.</a:t>
             </a:r>
             <a:endParaRPr lang="en-US" sz="1400" dirty="0"/>
           </a:p>
@@ -3546,7 +3546,7 @@
                   <a:schemeClr val="tx1"/>
                 </a:solidFill>
               </a:rPr>
-              <a:t>Other CCTP chain</a:t>
+              <a:t>Direct CCTP mint</a:t>
             </a:r>
             <a:endParaRPr lang="en-US" sz="1400" dirty="0"/>
           </a:p>
@@ -3560,7 +3560,7 @@
                   <a:schemeClr val="tx2"/>
                 </a:solidFill>
               </a:rPr>
-              <a:t>CCTP mint, then settle()</a:t>
+              <a:t>Outside the app, then settle()</a:t>
             </a:r>
             <a:endParaRPr lang="en-US" sz="1400" dirty="0"/>
           </a:p>
@@ -5919,7 +5919,7 @@
                 <a:ea typeface="Arial" pitchFamily="34" charset="-122"/>
                 <a:cs typeface="Arial" pitchFamily="34" charset="-120"/>
               </a:rPr>
-              <a:t>The owner never touches the funds</a:t>
+              <a:t>The owner never touches creator balances</a:t>
             </a:r>
             <a:endParaRPr lang="en-US" sz="2600" dirty="0"/>
           </a:p>
@@ -5951,6 +5951,10 @@
             <a:prstDash val="solid"/>
           </a:ln>
         </p:spPr>
+        <p:txBody>
+          <a:bodyPr/>
+          <a:p/>
+        </p:txBody>
       </p:sp>
       <p:sp>
         <p:nvSpPr>
@@ -6050,6 +6054,10 @@
             <a:prstDash val="solid"/>
           </a:ln>
         </p:spPr>
+        <p:txBody>
+          <a:bodyPr/>
+          <a:p/>
+        </p:txBody>
       </p:sp>
       <p:sp>
         <p:nvSpPr>
@@ -6149,6 +6157,10 @@
             <a:prstDash val="solid"/>
           </a:ln>
         </p:spPr>
+        <p:txBody>
+          <a:bodyPr/>
+          <a:p/>
+        </p:txBody>
       </p:sp>
       <p:sp>
         <p:nvSpPr>
@@ -6802,7 +6814,7 @@
                   <a:schemeClr val="tx1"/>
                 </a:solidFill>
               </a:rPr>
-              <a:t>Unit, fuzz, invariant and Arc mainnet fork tests. Slither findings documented. Money tests run on Arc testnet.</a:t>
+              <a:t>Unit, fuzz, invariant and Arc mainnet fork tests. Slither findings documented. Money tests move to Arc testnet next.</a:t>
             </a:r>
             <a:endParaRPr lang="en-US" sz="1400" dirty="0"/>
           </a:p>

</xml_diff>

<commit_message>
docs: testnet live in deck and whitepaper PDF
</commit_message>
<xml_diff>
--- a/docs/fundit-pitch-deck.pptx
+++ b/docs/fundit-pitch-deck.pptx
@@ -822,7 +822,7 @@
           <a:p>
             <a:r>
               <a:rPr lang="en-US" dirty="0"/>
-              <a:t>0:30 to 1:45. Demo on an Arc testnet build. Testnet testing is set up, and the testnet factory deploy is pending, so the demo waits for it. Demo path: sign in with a passkey, save the recovery key, add money, create a Fundit, give 1 USDC with a tip and a message, show the activity list and explorer link, then withdraw to Base Sepolia.</a:t>
+              <a:t>0:30 to 1:45. Demo on an Arc testnet build, against the testnet factory. Demo path: sign in with a passkey, save the recovery key, add money, create a Fundit, give 1 USDC with a tip and a message, show the activity list and explorer link, then withdraw to Base Sepolia.</a:t>
             </a:r>
             <a:endParaRPr lang="en-US" dirty="0"/>
           </a:p>
@@ -1262,7 +1262,7 @@
           <a:p>
             <a:r>
               <a:rPr lang="en-US" dirty="0"/>
-              <a:t>3:15 to 3:45. Contracts live on Arc mainnet. Testnet testing is set up, and the testnet factory deploy is pending. No traction numbers yet. Every number we report later comes from on-chain data.</a:t>
+              <a:t>3:15 to 3:45. Contracts live on Arc mainnet and Arc testnet. Testing runs on Arc testnet today: the end-to-end suite signs up with a virtual passkey and runs every money flow there. No traction numbers yet. Every number we report later comes from on-chain data.</a:t>
             </a:r>
             <a:endParaRPr lang="en-US" dirty="0"/>
           </a:p>
@@ -6814,7 +6814,7 @@
                   <a:schemeClr val="tx1"/>
                 </a:solidFill>
               </a:rPr>
-              <a:t>Unit, fuzz, invariant and Arc mainnet fork tests. Slither findings documented. Money tests move to Arc testnet next.</a:t>
+              <a:t>Unit, fuzz, invariant and Arc mainnet fork tests. Slither findings documented. Money tests run on Arc testnet.</a:t>
             </a:r>
             <a:endParaRPr lang="en-US" sz="1400" dirty="0"/>
           </a:p>

</xml_diff>